<commit_message>
update and add new ppts
</commit_message>
<xml_diff>
--- a/宣道詩/(宣道詩138)全告知耶穌.pptx
+++ b/宣道詩/(宣道詩138)全告知耶穌.pptx
@@ -122,7 +122,18 @@
   </p:defaultTextStyle>
   <p:extLst>
     <p:ext uri="{EFAFB233-063F-42B5-8137-9DF3F51BA10A}">
-      <p15:sldGuideLst xmlns="" xmlns:p15="http://schemas.microsoft.com/office/powerpoint/2012/main"/>
+      <p15:sldGuideLst xmlns:p15="http://schemas.microsoft.com/office/powerpoint/2012/main">
+        <p15:guide id="1" orient="horz" pos="2160">
+          <p15:clr>
+            <a:srgbClr val="A4A3A4"/>
+          </p15:clr>
+        </p15:guide>
+        <p15:guide id="2" pos="3840">
+          <p15:clr>
+            <a:srgbClr val="A4A3A4"/>
+          </p15:clr>
+        </p15:guide>
+      </p15:sldGuideLst>
     </p:ext>
   </p:extLst>
 </p:presentation>
@@ -166,7 +177,7 @@
           <a:lstStyle/>
           <a:p>
             <a:r>
-              <a:rPr lang="en-US" altLang="zh-TW" smtClean="0"/>
+              <a:rPr lang="en-US" altLang="zh-TW"/>
               <a:t>Click to edit Master title style</a:t>
             </a:r>
             <a:endParaRPr lang="zh-TW" altLang="en-US"/>
@@ -285,7 +296,7 @@
           </a:lstStyle>
           <a:p>
             <a:r>
-              <a:rPr lang="en-US" altLang="zh-TW" smtClean="0"/>
+              <a:rPr lang="en-US" altLang="zh-TW"/>
               <a:t>Click to edit Master subtitle style</a:t>
             </a:r>
             <a:endParaRPr lang="zh-TW" altLang="en-US"/>
@@ -310,7 +321,7 @@
             <a:fld id="{3F2C6D9B-8CE1-4066-A051-C4E0F63D835E}" type="datetimeFigureOut">
               <a:rPr lang="vi-VN" smtClean="0"/>
               <a:pPr/>
-              <a:t>08/12/2022</a:t>
+              <a:t>08/05/2026</a:t>
             </a:fld>
             <a:endParaRPr lang="vi-VN"/>
           </a:p>
@@ -362,7 +373,7 @@
     </p:spTree>
     <p:extLst>
       <p:ext uri="{BB962C8B-B14F-4D97-AF65-F5344CB8AC3E}">
-        <p14:creationId xmlns="" xmlns:p14="http://schemas.microsoft.com/office/powerpoint/2010/main" val="1621036267"/>
+        <p14:creationId xmlns:p14="http://schemas.microsoft.com/office/powerpoint/2010/main" val="1621036267"/>
       </p:ext>
     </p:extLst>
   </p:cSld>
@@ -405,7 +416,7 @@
           <a:lstStyle/>
           <a:p>
             <a:r>
-              <a:rPr lang="en-US" altLang="zh-TW" smtClean="0"/>
+              <a:rPr lang="en-US" altLang="zh-TW"/>
               <a:t>Click to edit Master title style</a:t>
             </a:r>
             <a:endParaRPr lang="zh-TW" altLang="en-US"/>
@@ -429,35 +440,35 @@
           <a:p>
             <a:pPr lvl="0"/>
             <a:r>
-              <a:rPr lang="en-US" altLang="zh-TW" smtClean="0"/>
+              <a:rPr lang="en-US" altLang="zh-TW"/>
               <a:t>Edit Master text styles</a:t>
             </a:r>
           </a:p>
           <a:p>
             <a:pPr lvl="1"/>
             <a:r>
-              <a:rPr lang="en-US" altLang="zh-TW" smtClean="0"/>
+              <a:rPr lang="en-US" altLang="zh-TW"/>
               <a:t>Second level</a:t>
             </a:r>
           </a:p>
           <a:p>
             <a:pPr lvl="2"/>
             <a:r>
-              <a:rPr lang="en-US" altLang="zh-TW" smtClean="0"/>
+              <a:rPr lang="en-US" altLang="zh-TW"/>
               <a:t>Third level</a:t>
             </a:r>
           </a:p>
           <a:p>
             <a:pPr lvl="3"/>
             <a:r>
-              <a:rPr lang="en-US" altLang="zh-TW" smtClean="0"/>
+              <a:rPr lang="en-US" altLang="zh-TW"/>
               <a:t>Fourth level</a:t>
             </a:r>
           </a:p>
           <a:p>
             <a:pPr lvl="4"/>
             <a:r>
-              <a:rPr lang="en-US" altLang="zh-TW" smtClean="0"/>
+              <a:rPr lang="en-US" altLang="zh-TW"/>
               <a:t>Fifth level</a:t>
             </a:r>
             <a:endParaRPr lang="zh-TW" altLang="en-US"/>
@@ -482,7 +493,7 @@
             <a:fld id="{3F2C6D9B-8CE1-4066-A051-C4E0F63D835E}" type="datetimeFigureOut">
               <a:rPr lang="vi-VN" smtClean="0"/>
               <a:pPr/>
-              <a:t>08/12/2022</a:t>
+              <a:t>08/05/2026</a:t>
             </a:fld>
             <a:endParaRPr lang="vi-VN"/>
           </a:p>
@@ -534,7 +545,7 @@
     </p:spTree>
     <p:extLst>
       <p:ext uri="{BB962C8B-B14F-4D97-AF65-F5344CB8AC3E}">
-        <p14:creationId xmlns="" xmlns:p14="http://schemas.microsoft.com/office/powerpoint/2010/main" val="2068198638"/>
+        <p14:creationId xmlns:p14="http://schemas.microsoft.com/office/powerpoint/2010/main" val="2068198638"/>
       </p:ext>
     </p:extLst>
   </p:cSld>
@@ -582,7 +593,7 @@
           <a:lstStyle/>
           <a:p>
             <a:r>
-              <a:rPr lang="en-US" altLang="zh-TW" smtClean="0"/>
+              <a:rPr lang="en-US" altLang="zh-TW"/>
               <a:t>Click to edit Master title style</a:t>
             </a:r>
             <a:endParaRPr lang="zh-TW" altLang="en-US"/>
@@ -611,35 +622,35 @@
           <a:p>
             <a:pPr lvl="0"/>
             <a:r>
-              <a:rPr lang="en-US" altLang="zh-TW" smtClean="0"/>
+              <a:rPr lang="en-US" altLang="zh-TW"/>
               <a:t>Edit Master text styles</a:t>
             </a:r>
           </a:p>
           <a:p>
             <a:pPr lvl="1"/>
             <a:r>
-              <a:rPr lang="en-US" altLang="zh-TW" smtClean="0"/>
+              <a:rPr lang="en-US" altLang="zh-TW"/>
               <a:t>Second level</a:t>
             </a:r>
           </a:p>
           <a:p>
             <a:pPr lvl="2"/>
             <a:r>
-              <a:rPr lang="en-US" altLang="zh-TW" smtClean="0"/>
+              <a:rPr lang="en-US" altLang="zh-TW"/>
               <a:t>Third level</a:t>
             </a:r>
           </a:p>
           <a:p>
             <a:pPr lvl="3"/>
             <a:r>
-              <a:rPr lang="en-US" altLang="zh-TW" smtClean="0"/>
+              <a:rPr lang="en-US" altLang="zh-TW"/>
               <a:t>Fourth level</a:t>
             </a:r>
           </a:p>
           <a:p>
             <a:pPr lvl="4"/>
             <a:r>
-              <a:rPr lang="en-US" altLang="zh-TW" smtClean="0"/>
+              <a:rPr lang="en-US" altLang="zh-TW"/>
               <a:t>Fifth level</a:t>
             </a:r>
             <a:endParaRPr lang="zh-TW" altLang="en-US"/>
@@ -664,7 +675,7 @@
             <a:fld id="{3F2C6D9B-8CE1-4066-A051-C4E0F63D835E}" type="datetimeFigureOut">
               <a:rPr lang="vi-VN" smtClean="0"/>
               <a:pPr/>
-              <a:t>08/12/2022</a:t>
+              <a:t>08/05/2026</a:t>
             </a:fld>
             <a:endParaRPr lang="vi-VN"/>
           </a:p>
@@ -716,7 +727,7 @@
     </p:spTree>
     <p:extLst>
       <p:ext uri="{BB962C8B-B14F-4D97-AF65-F5344CB8AC3E}">
-        <p14:creationId xmlns="" xmlns:p14="http://schemas.microsoft.com/office/powerpoint/2010/main" val="3737284981"/>
+        <p14:creationId xmlns:p14="http://schemas.microsoft.com/office/powerpoint/2010/main" val="3737284981"/>
       </p:ext>
     </p:extLst>
   </p:cSld>
@@ -759,7 +770,7 @@
           <a:lstStyle/>
           <a:p>
             <a:r>
-              <a:rPr lang="en-US" altLang="zh-TW" smtClean="0"/>
+              <a:rPr lang="en-US" altLang="zh-TW"/>
               <a:t>Click to edit Master title style</a:t>
             </a:r>
             <a:endParaRPr lang="zh-TW" altLang="en-US"/>
@@ -783,35 +794,35 @@
           <a:p>
             <a:pPr lvl="0"/>
             <a:r>
-              <a:rPr lang="en-US" altLang="zh-TW" smtClean="0"/>
+              <a:rPr lang="en-US" altLang="zh-TW"/>
               <a:t>Edit Master text styles</a:t>
             </a:r>
           </a:p>
           <a:p>
             <a:pPr lvl="1"/>
             <a:r>
-              <a:rPr lang="en-US" altLang="zh-TW" smtClean="0"/>
+              <a:rPr lang="en-US" altLang="zh-TW"/>
               <a:t>Second level</a:t>
             </a:r>
           </a:p>
           <a:p>
             <a:pPr lvl="2"/>
             <a:r>
-              <a:rPr lang="en-US" altLang="zh-TW" smtClean="0"/>
+              <a:rPr lang="en-US" altLang="zh-TW"/>
               <a:t>Third level</a:t>
             </a:r>
           </a:p>
           <a:p>
             <a:pPr lvl="3"/>
             <a:r>
-              <a:rPr lang="en-US" altLang="zh-TW" smtClean="0"/>
+              <a:rPr lang="en-US" altLang="zh-TW"/>
               <a:t>Fourth level</a:t>
             </a:r>
           </a:p>
           <a:p>
             <a:pPr lvl="4"/>
             <a:r>
-              <a:rPr lang="en-US" altLang="zh-TW" smtClean="0"/>
+              <a:rPr lang="en-US" altLang="zh-TW"/>
               <a:t>Fifth level</a:t>
             </a:r>
             <a:endParaRPr lang="zh-TW" altLang="en-US"/>
@@ -836,7 +847,7 @@
             <a:fld id="{3F2C6D9B-8CE1-4066-A051-C4E0F63D835E}" type="datetimeFigureOut">
               <a:rPr lang="vi-VN" smtClean="0"/>
               <a:pPr/>
-              <a:t>08/12/2022</a:t>
+              <a:t>08/05/2026</a:t>
             </a:fld>
             <a:endParaRPr lang="vi-VN"/>
           </a:p>
@@ -888,7 +899,7 @@
     </p:spTree>
     <p:extLst>
       <p:ext uri="{BB962C8B-B14F-4D97-AF65-F5344CB8AC3E}">
-        <p14:creationId xmlns="" xmlns:p14="http://schemas.microsoft.com/office/powerpoint/2010/main" val="1499790127"/>
+        <p14:creationId xmlns:p14="http://schemas.microsoft.com/office/powerpoint/2010/main" val="1499790127"/>
       </p:ext>
     </p:extLst>
   </p:cSld>
@@ -940,7 +951,7 @@
           </a:lstStyle>
           <a:p>
             <a:r>
-              <a:rPr lang="en-US" altLang="zh-TW" smtClean="0"/>
+              <a:rPr lang="en-US" altLang="zh-TW"/>
               <a:t>Click to edit Master title style</a:t>
             </a:r>
             <a:endParaRPr lang="zh-TW" altLang="en-US"/>
@@ -1060,7 +1071,7 @@
           <a:p>
             <a:pPr lvl="0"/>
             <a:r>
-              <a:rPr lang="en-US" altLang="zh-TW" smtClean="0"/>
+              <a:rPr lang="en-US" altLang="zh-TW"/>
               <a:t>Edit Master text styles</a:t>
             </a:r>
           </a:p>
@@ -1084,7 +1095,7 @@
             <a:fld id="{3F2C6D9B-8CE1-4066-A051-C4E0F63D835E}" type="datetimeFigureOut">
               <a:rPr lang="vi-VN" smtClean="0"/>
               <a:pPr/>
-              <a:t>08/12/2022</a:t>
+              <a:t>08/05/2026</a:t>
             </a:fld>
             <a:endParaRPr lang="vi-VN"/>
           </a:p>
@@ -1136,7 +1147,7 @@
     </p:spTree>
     <p:extLst>
       <p:ext uri="{BB962C8B-B14F-4D97-AF65-F5344CB8AC3E}">
-        <p14:creationId xmlns="" xmlns:p14="http://schemas.microsoft.com/office/powerpoint/2010/main" val="857958680"/>
+        <p14:creationId xmlns:p14="http://schemas.microsoft.com/office/powerpoint/2010/main" val="857958680"/>
       </p:ext>
     </p:extLst>
   </p:cSld>
@@ -1179,7 +1190,7 @@
           <a:lstStyle/>
           <a:p>
             <a:r>
-              <a:rPr lang="en-US" altLang="zh-TW" smtClean="0"/>
+              <a:rPr lang="en-US" altLang="zh-TW"/>
               <a:t>Click to edit Master title style</a:t>
             </a:r>
             <a:endParaRPr lang="zh-TW" altLang="en-US"/>
@@ -1236,35 +1247,35 @@
           <a:p>
             <a:pPr lvl="0"/>
             <a:r>
-              <a:rPr lang="en-US" altLang="zh-TW" smtClean="0"/>
+              <a:rPr lang="en-US" altLang="zh-TW"/>
               <a:t>Edit Master text styles</a:t>
             </a:r>
           </a:p>
           <a:p>
             <a:pPr lvl="1"/>
             <a:r>
-              <a:rPr lang="en-US" altLang="zh-TW" smtClean="0"/>
+              <a:rPr lang="en-US" altLang="zh-TW"/>
               <a:t>Second level</a:t>
             </a:r>
           </a:p>
           <a:p>
             <a:pPr lvl="2"/>
             <a:r>
-              <a:rPr lang="en-US" altLang="zh-TW" smtClean="0"/>
+              <a:rPr lang="en-US" altLang="zh-TW"/>
               <a:t>Third level</a:t>
             </a:r>
           </a:p>
           <a:p>
             <a:pPr lvl="3"/>
             <a:r>
-              <a:rPr lang="en-US" altLang="zh-TW" smtClean="0"/>
+              <a:rPr lang="en-US" altLang="zh-TW"/>
               <a:t>Fourth level</a:t>
             </a:r>
           </a:p>
           <a:p>
             <a:pPr lvl="4"/>
             <a:r>
-              <a:rPr lang="en-US" altLang="zh-TW" smtClean="0"/>
+              <a:rPr lang="en-US" altLang="zh-TW"/>
               <a:t>Fifth level</a:t>
             </a:r>
             <a:endParaRPr lang="zh-TW" altLang="en-US"/>
@@ -1321,35 +1332,35 @@
           <a:p>
             <a:pPr lvl="0"/>
             <a:r>
-              <a:rPr lang="en-US" altLang="zh-TW" smtClean="0"/>
+              <a:rPr lang="en-US" altLang="zh-TW"/>
               <a:t>Edit Master text styles</a:t>
             </a:r>
           </a:p>
           <a:p>
             <a:pPr lvl="1"/>
             <a:r>
-              <a:rPr lang="en-US" altLang="zh-TW" smtClean="0"/>
+              <a:rPr lang="en-US" altLang="zh-TW"/>
               <a:t>Second level</a:t>
             </a:r>
           </a:p>
           <a:p>
             <a:pPr lvl="2"/>
             <a:r>
-              <a:rPr lang="en-US" altLang="zh-TW" smtClean="0"/>
+              <a:rPr lang="en-US" altLang="zh-TW"/>
               <a:t>Third level</a:t>
             </a:r>
           </a:p>
           <a:p>
             <a:pPr lvl="3"/>
             <a:r>
-              <a:rPr lang="en-US" altLang="zh-TW" smtClean="0"/>
+              <a:rPr lang="en-US" altLang="zh-TW"/>
               <a:t>Fourth level</a:t>
             </a:r>
           </a:p>
           <a:p>
             <a:pPr lvl="4"/>
             <a:r>
-              <a:rPr lang="en-US" altLang="zh-TW" smtClean="0"/>
+              <a:rPr lang="en-US" altLang="zh-TW"/>
               <a:t>Fifth level</a:t>
             </a:r>
             <a:endParaRPr lang="zh-TW" altLang="en-US"/>
@@ -1374,7 +1385,7 @@
             <a:fld id="{3F2C6D9B-8CE1-4066-A051-C4E0F63D835E}" type="datetimeFigureOut">
               <a:rPr lang="vi-VN" smtClean="0"/>
               <a:pPr/>
-              <a:t>08/12/2022</a:t>
+              <a:t>08/05/2026</a:t>
             </a:fld>
             <a:endParaRPr lang="vi-VN"/>
           </a:p>
@@ -1426,7 +1437,7 @@
     </p:spTree>
     <p:extLst>
       <p:ext uri="{BB962C8B-B14F-4D97-AF65-F5344CB8AC3E}">
-        <p14:creationId xmlns="" xmlns:p14="http://schemas.microsoft.com/office/powerpoint/2010/main" val="398883193"/>
+        <p14:creationId xmlns:p14="http://schemas.microsoft.com/office/powerpoint/2010/main" val="398883193"/>
       </p:ext>
     </p:extLst>
   </p:cSld>
@@ -1473,7 +1484,7 @@
           </a:lstStyle>
           <a:p>
             <a:r>
-              <a:rPr lang="en-US" altLang="zh-TW" smtClean="0"/>
+              <a:rPr lang="en-US" altLang="zh-TW"/>
               <a:t>Click to edit Master title style</a:t>
             </a:r>
             <a:endParaRPr lang="zh-TW" altLang="en-US"/>
@@ -1539,7 +1550,7 @@
           <a:p>
             <a:pPr lvl="0"/>
             <a:r>
-              <a:rPr lang="en-US" altLang="zh-TW" smtClean="0"/>
+              <a:rPr lang="en-US" altLang="zh-TW"/>
               <a:t>Edit Master text styles</a:t>
             </a:r>
           </a:p>
@@ -1595,35 +1606,35 @@
           <a:p>
             <a:pPr lvl="0"/>
             <a:r>
-              <a:rPr lang="en-US" altLang="zh-TW" smtClean="0"/>
+              <a:rPr lang="en-US" altLang="zh-TW"/>
               <a:t>Edit Master text styles</a:t>
             </a:r>
           </a:p>
           <a:p>
             <a:pPr lvl="1"/>
             <a:r>
-              <a:rPr lang="en-US" altLang="zh-TW" smtClean="0"/>
+              <a:rPr lang="en-US" altLang="zh-TW"/>
               <a:t>Second level</a:t>
             </a:r>
           </a:p>
           <a:p>
             <a:pPr lvl="2"/>
             <a:r>
-              <a:rPr lang="en-US" altLang="zh-TW" smtClean="0"/>
+              <a:rPr lang="en-US" altLang="zh-TW"/>
               <a:t>Third level</a:t>
             </a:r>
           </a:p>
           <a:p>
             <a:pPr lvl="3"/>
             <a:r>
-              <a:rPr lang="en-US" altLang="zh-TW" smtClean="0"/>
+              <a:rPr lang="en-US" altLang="zh-TW"/>
               <a:t>Fourth level</a:t>
             </a:r>
           </a:p>
           <a:p>
             <a:pPr lvl="4"/>
             <a:r>
-              <a:rPr lang="en-US" altLang="zh-TW" smtClean="0"/>
+              <a:rPr lang="en-US" altLang="zh-TW"/>
               <a:t>Fifth level</a:t>
             </a:r>
             <a:endParaRPr lang="zh-TW" altLang="en-US"/>
@@ -1689,7 +1700,7 @@
           <a:p>
             <a:pPr lvl="0"/>
             <a:r>
-              <a:rPr lang="en-US" altLang="zh-TW" smtClean="0"/>
+              <a:rPr lang="en-US" altLang="zh-TW"/>
               <a:t>Edit Master text styles</a:t>
             </a:r>
           </a:p>
@@ -1745,35 +1756,35 @@
           <a:p>
             <a:pPr lvl="0"/>
             <a:r>
-              <a:rPr lang="en-US" altLang="zh-TW" smtClean="0"/>
+              <a:rPr lang="en-US" altLang="zh-TW"/>
               <a:t>Edit Master text styles</a:t>
             </a:r>
           </a:p>
           <a:p>
             <a:pPr lvl="1"/>
             <a:r>
-              <a:rPr lang="en-US" altLang="zh-TW" smtClean="0"/>
+              <a:rPr lang="en-US" altLang="zh-TW"/>
               <a:t>Second level</a:t>
             </a:r>
           </a:p>
           <a:p>
             <a:pPr lvl="2"/>
             <a:r>
-              <a:rPr lang="en-US" altLang="zh-TW" smtClean="0"/>
+              <a:rPr lang="en-US" altLang="zh-TW"/>
               <a:t>Third level</a:t>
             </a:r>
           </a:p>
           <a:p>
             <a:pPr lvl="3"/>
             <a:r>
-              <a:rPr lang="en-US" altLang="zh-TW" smtClean="0"/>
+              <a:rPr lang="en-US" altLang="zh-TW"/>
               <a:t>Fourth level</a:t>
             </a:r>
           </a:p>
           <a:p>
             <a:pPr lvl="4"/>
             <a:r>
-              <a:rPr lang="en-US" altLang="zh-TW" smtClean="0"/>
+              <a:rPr lang="en-US" altLang="zh-TW"/>
               <a:t>Fifth level</a:t>
             </a:r>
             <a:endParaRPr lang="zh-TW" altLang="en-US"/>
@@ -1798,7 +1809,7 @@
             <a:fld id="{3F2C6D9B-8CE1-4066-A051-C4E0F63D835E}" type="datetimeFigureOut">
               <a:rPr lang="vi-VN" smtClean="0"/>
               <a:pPr/>
-              <a:t>08/12/2022</a:t>
+              <a:t>08/05/2026</a:t>
             </a:fld>
             <a:endParaRPr lang="vi-VN"/>
           </a:p>
@@ -1850,7 +1861,7 @@
     </p:spTree>
     <p:extLst>
       <p:ext uri="{BB962C8B-B14F-4D97-AF65-F5344CB8AC3E}">
-        <p14:creationId xmlns="" xmlns:p14="http://schemas.microsoft.com/office/powerpoint/2010/main" val="109706588"/>
+        <p14:creationId xmlns:p14="http://schemas.microsoft.com/office/powerpoint/2010/main" val="109706588"/>
       </p:ext>
     </p:extLst>
   </p:cSld>
@@ -1893,7 +1904,7 @@
           <a:lstStyle/>
           <a:p>
             <a:r>
-              <a:rPr lang="en-US" altLang="zh-TW" smtClean="0"/>
+              <a:rPr lang="en-US" altLang="zh-TW"/>
               <a:t>Click to edit Master title style</a:t>
             </a:r>
             <a:endParaRPr lang="zh-TW" altLang="en-US"/>
@@ -1918,7 +1929,7 @@
             <a:fld id="{3F2C6D9B-8CE1-4066-A051-C4E0F63D835E}" type="datetimeFigureOut">
               <a:rPr lang="vi-VN" smtClean="0"/>
               <a:pPr/>
-              <a:t>08/12/2022</a:t>
+              <a:t>08/05/2026</a:t>
             </a:fld>
             <a:endParaRPr lang="vi-VN"/>
           </a:p>
@@ -1970,7 +1981,7 @@
     </p:spTree>
     <p:extLst>
       <p:ext uri="{BB962C8B-B14F-4D97-AF65-F5344CB8AC3E}">
-        <p14:creationId xmlns="" xmlns:p14="http://schemas.microsoft.com/office/powerpoint/2010/main" val="2343813325"/>
+        <p14:creationId xmlns:p14="http://schemas.microsoft.com/office/powerpoint/2010/main" val="2343813325"/>
       </p:ext>
     </p:extLst>
   </p:cSld>
@@ -2015,7 +2026,7 @@
             <a:fld id="{3F2C6D9B-8CE1-4066-A051-C4E0F63D835E}" type="datetimeFigureOut">
               <a:rPr lang="vi-VN" smtClean="0"/>
               <a:pPr/>
-              <a:t>08/12/2022</a:t>
+              <a:t>08/05/2026</a:t>
             </a:fld>
             <a:endParaRPr lang="vi-VN"/>
           </a:p>
@@ -2067,7 +2078,7 @@
     </p:spTree>
     <p:extLst>
       <p:ext uri="{BB962C8B-B14F-4D97-AF65-F5344CB8AC3E}">
-        <p14:creationId xmlns="" xmlns:p14="http://schemas.microsoft.com/office/powerpoint/2010/main" val="2350996812"/>
+        <p14:creationId xmlns:p14="http://schemas.microsoft.com/office/powerpoint/2010/main" val="2350996812"/>
       </p:ext>
     </p:extLst>
   </p:cSld>
@@ -2119,7 +2130,7 @@
           </a:lstStyle>
           <a:p>
             <a:r>
-              <a:rPr lang="en-US" altLang="zh-TW" smtClean="0"/>
+              <a:rPr lang="en-US" altLang="zh-TW"/>
               <a:t>Click to edit Master title style</a:t>
             </a:r>
             <a:endParaRPr lang="zh-TW" altLang="en-US"/>
@@ -2176,35 +2187,35 @@
           <a:p>
             <a:pPr lvl="0"/>
             <a:r>
-              <a:rPr lang="en-US" altLang="zh-TW" smtClean="0"/>
+              <a:rPr lang="en-US" altLang="zh-TW"/>
               <a:t>Edit Master text styles</a:t>
             </a:r>
           </a:p>
           <a:p>
             <a:pPr lvl="1"/>
             <a:r>
-              <a:rPr lang="en-US" altLang="zh-TW" smtClean="0"/>
+              <a:rPr lang="en-US" altLang="zh-TW"/>
               <a:t>Second level</a:t>
             </a:r>
           </a:p>
           <a:p>
             <a:pPr lvl="2"/>
             <a:r>
-              <a:rPr lang="en-US" altLang="zh-TW" smtClean="0"/>
+              <a:rPr lang="en-US" altLang="zh-TW"/>
               <a:t>Third level</a:t>
             </a:r>
           </a:p>
           <a:p>
             <a:pPr lvl="3"/>
             <a:r>
-              <a:rPr lang="en-US" altLang="zh-TW" smtClean="0"/>
+              <a:rPr lang="en-US" altLang="zh-TW"/>
               <a:t>Fourth level</a:t>
             </a:r>
           </a:p>
           <a:p>
             <a:pPr lvl="4"/>
             <a:r>
-              <a:rPr lang="en-US" altLang="zh-TW" smtClean="0"/>
+              <a:rPr lang="en-US" altLang="zh-TW"/>
               <a:t>Fifth level</a:t>
             </a:r>
             <a:endParaRPr lang="zh-TW" altLang="en-US"/>
@@ -2270,7 +2281,7 @@
           <a:p>
             <a:pPr lvl="0"/>
             <a:r>
-              <a:rPr lang="en-US" altLang="zh-TW" smtClean="0"/>
+              <a:rPr lang="en-US" altLang="zh-TW"/>
               <a:t>Edit Master text styles</a:t>
             </a:r>
           </a:p>
@@ -2294,7 +2305,7 @@
             <a:fld id="{3F2C6D9B-8CE1-4066-A051-C4E0F63D835E}" type="datetimeFigureOut">
               <a:rPr lang="vi-VN" smtClean="0"/>
               <a:pPr/>
-              <a:t>08/12/2022</a:t>
+              <a:t>08/05/2026</a:t>
             </a:fld>
             <a:endParaRPr lang="vi-VN"/>
           </a:p>
@@ -2346,7 +2357,7 @@
     </p:spTree>
     <p:extLst>
       <p:ext uri="{BB962C8B-B14F-4D97-AF65-F5344CB8AC3E}">
-        <p14:creationId xmlns="" xmlns:p14="http://schemas.microsoft.com/office/powerpoint/2010/main" val="4020908913"/>
+        <p14:creationId xmlns:p14="http://schemas.microsoft.com/office/powerpoint/2010/main" val="4020908913"/>
       </p:ext>
     </p:extLst>
   </p:cSld>
@@ -2398,7 +2409,7 @@
           </a:lstStyle>
           <a:p>
             <a:r>
-              <a:rPr lang="en-US" altLang="zh-TW" smtClean="0"/>
+              <a:rPr lang="en-US" altLang="zh-TW"/>
               <a:t>Click to edit Master title style</a:t>
             </a:r>
             <a:endParaRPr lang="zh-TW" altLang="en-US"/>
@@ -2463,7 +2474,7 @@
           </a:lstStyle>
           <a:p>
             <a:r>
-              <a:rPr lang="en-US" altLang="zh-TW" smtClean="0"/>
+              <a:rPr lang="en-US" altLang="zh-TW"/>
               <a:t>Click icon to add picture</a:t>
             </a:r>
             <a:endParaRPr lang="zh-TW" altLang="en-US"/>
@@ -2529,7 +2540,7 @@
           <a:p>
             <a:pPr lvl="0"/>
             <a:r>
-              <a:rPr lang="en-US" altLang="zh-TW" smtClean="0"/>
+              <a:rPr lang="en-US" altLang="zh-TW"/>
               <a:t>Edit Master text styles</a:t>
             </a:r>
           </a:p>
@@ -2553,7 +2564,7 @@
             <a:fld id="{3F2C6D9B-8CE1-4066-A051-C4E0F63D835E}" type="datetimeFigureOut">
               <a:rPr lang="vi-VN" smtClean="0"/>
               <a:pPr/>
-              <a:t>08/12/2022</a:t>
+              <a:t>08/05/2026</a:t>
             </a:fld>
             <a:endParaRPr lang="vi-VN"/>
           </a:p>
@@ -2605,7 +2616,7 @@
     </p:spTree>
     <p:extLst>
       <p:ext uri="{BB962C8B-B14F-4D97-AF65-F5344CB8AC3E}">
-        <p14:creationId xmlns="" xmlns:p14="http://schemas.microsoft.com/office/powerpoint/2010/main" val="3326449524"/>
+        <p14:creationId xmlns:p14="http://schemas.microsoft.com/office/powerpoint/2010/main" val="3326449524"/>
       </p:ext>
     </p:extLst>
   </p:cSld>
@@ -2668,10 +2679,9 @@
           <a:lstStyle/>
           <a:p>
             <a:r>
-              <a:rPr lang="zh-TW" altLang="en-US" smtClean="0"/>
+              <a:rPr lang="zh-TW" altLang="en-US"/>
               <a:t>按一下以編輯母片標題樣式</a:t>
             </a:r>
-            <a:endParaRPr lang="zh-TW" altLang="en-US"/>
           </a:p>
         </p:txBody>
       </p:sp>
@@ -2702,38 +2712,37 @@
           <a:p>
             <a:pPr lvl="0"/>
             <a:r>
-              <a:rPr lang="zh-TW" altLang="en-US" smtClean="0"/>
+              <a:rPr lang="zh-TW" altLang="en-US"/>
               <a:t>按一下以編輯母片文字樣式</a:t>
             </a:r>
           </a:p>
           <a:p>
             <a:pPr lvl="1"/>
             <a:r>
-              <a:rPr lang="zh-TW" altLang="en-US" smtClean="0"/>
+              <a:rPr lang="zh-TW" altLang="en-US"/>
               <a:t>第二層</a:t>
             </a:r>
           </a:p>
           <a:p>
             <a:pPr lvl="2"/>
             <a:r>
-              <a:rPr lang="zh-TW" altLang="en-US" smtClean="0"/>
+              <a:rPr lang="zh-TW" altLang="en-US"/>
               <a:t>第三層</a:t>
             </a:r>
           </a:p>
           <a:p>
             <a:pPr lvl="3"/>
             <a:r>
-              <a:rPr lang="zh-TW" altLang="en-US" smtClean="0"/>
+              <a:rPr lang="zh-TW" altLang="en-US"/>
               <a:t>第四層</a:t>
             </a:r>
           </a:p>
           <a:p>
             <a:pPr lvl="4"/>
             <a:r>
-              <a:rPr lang="zh-TW" altLang="en-US" smtClean="0"/>
+              <a:rPr lang="zh-TW" altLang="en-US"/>
               <a:t>第五層</a:t>
             </a:r>
-            <a:endParaRPr lang="zh-TW" altLang="en-US"/>
           </a:p>
         </p:txBody>
       </p:sp>
@@ -2773,7 +2782,7 @@
             <a:fld id="{3F2C6D9B-8CE1-4066-A051-C4E0F63D835E}" type="datetimeFigureOut">
               <a:rPr lang="vi-VN" smtClean="0"/>
               <a:pPr/>
-              <a:t>08/12/2022</a:t>
+              <a:t>08/05/2026</a:t>
             </a:fld>
             <a:endParaRPr lang="vi-VN"/>
           </a:p>
@@ -2861,7 +2870,7 @@
     </p:spTree>
     <p:extLst>
       <p:ext uri="{BB962C8B-B14F-4D97-AF65-F5344CB8AC3E}">
-        <p14:creationId xmlns="" xmlns:p14="http://schemas.microsoft.com/office/powerpoint/2010/main" val="1537450450"/>
+        <p14:creationId xmlns:p14="http://schemas.microsoft.com/office/powerpoint/2010/main" val="1537450450"/>
       </p:ext>
     </p:extLst>
   </p:cSld>
@@ -3189,7 +3198,7 @@
               <a:t>宣道詩 </a:t>
             </a:r>
             <a:r>
-              <a:rPr lang="en-US" altLang="zh-CN" sz="5333" b="1" u="sng" dirty="0" smtClean="0">
+              <a:rPr lang="en-US" altLang="zh-CN" sz="5333" b="1" u="sng" dirty="0">
                 <a:solidFill>
                   <a:srgbClr val="660033"/>
                 </a:solidFill>
@@ -3205,23 +3214,6 @@
               </a:rPr>
               <a:t>138</a:t>
             </a:r>
-            <a:r>
-              <a:rPr lang="en-US" altLang="zh-CN" sz="7200" b="1" i="1">
-                <a:solidFill>
-                  <a:srgbClr val="660033"/>
-                </a:solidFill>
-                <a:effectLst>
-                  <a:outerShdw blurRad="38100" dist="38100" dir="2700000" algn="tl">
-                    <a:srgbClr val="000000">
-                      <a:alpha val="43137"/>
-                    </a:srgbClr>
-                  </a:outerShdw>
-                </a:effectLst>
-                <a:latin typeface="微軟正黑體" pitchFamily="34" charset="-120"/>
-                <a:ea typeface="微軟正黑體" pitchFamily="34" charset="-120"/>
-              </a:rPr>
-              <a:t/>
-            </a:r>
             <a:br>
               <a:rPr lang="en-US" altLang="zh-CN" sz="7200" b="1" i="1">
                 <a:solidFill>
@@ -3239,7 +3231,7 @@
               </a:rPr>
             </a:br>
             <a:r>
-              <a:rPr lang="zh-CN" altLang="en-US" sz="8000" b="1" smtClean="0">
+              <a:rPr lang="zh-CN" altLang="en-US" sz="8000" b="1">
                 <a:solidFill>
                   <a:srgbClr val="000066"/>
                 </a:solidFill>
@@ -3275,20 +3267,13 @@
     </p:spTree>
     <p:extLst>
       <p:ext uri="{BB962C8B-B14F-4D97-AF65-F5344CB8AC3E}">
-        <p14:creationId xmlns="" xmlns:p14="http://schemas.microsoft.com/office/powerpoint/2010/main" val="1552955768"/>
+        <p14:creationId xmlns:p14="http://schemas.microsoft.com/office/powerpoint/2010/main" val="1552955768"/>
       </p:ext>
     </p:extLst>
   </p:cSld>
   <p:clrMapOvr>
     <a:masterClrMapping/>
   </p:clrMapOvr>
-  <p:timing>
-    <p:tnLst>
-      <p:par>
-        <p:cTn id="1" dur="indefinite" restart="never" nodeType="tmRoot"/>
-      </p:par>
-    </p:tnLst>
-  </p:timing>
 </p:sld>
 </file>
 
@@ -3400,12 +3385,12 @@
           <a:p>
             <a:pPr algn="ctr"/>
             <a:r>
-              <a:rPr lang="en-US" sz="5400" b="1" dirty="0" smtClean="0">
+              <a:rPr lang="en-US" sz="5400" b="1" dirty="0">
                 <a:solidFill>
                   <a:srgbClr val="000066"/>
                 </a:solidFill>
               </a:rPr>
-              <a:t>( 3 )</a:t>
+              <a:t>( 3 / 4 )</a:t>
             </a:r>
             <a:endParaRPr lang="vi-VN" sz="5400" b="1" dirty="0">
               <a:solidFill>
@@ -3418,20 +3403,13 @@
     </p:spTree>
     <p:extLst>
       <p:ext uri="{BB962C8B-B14F-4D97-AF65-F5344CB8AC3E}">
-        <p14:creationId xmlns="" xmlns:p14="http://schemas.microsoft.com/office/powerpoint/2010/main" val="3772975328"/>
+        <p14:creationId xmlns:p14="http://schemas.microsoft.com/office/powerpoint/2010/main" val="3772975328"/>
       </p:ext>
     </p:extLst>
   </p:cSld>
   <p:clrMapOvr>
     <a:masterClrMapping/>
   </p:clrMapOvr>
-  <p:timing>
-    <p:tnLst>
-      <p:par>
-        <p:cTn id="1" dur="indefinite" restart="never" nodeType="tmRoot"/>
-      </p:par>
-    </p:tnLst>
-  </p:timing>
 </p:sld>
 </file>
 
@@ -3478,24 +3456,14 @@
               <a:buNone/>
             </a:pPr>
             <a:r>
-              <a:rPr lang="zh-CN" altLang="en-US" sz="6400" b="1" dirty="0" smtClean="0">
+              <a:rPr lang="zh-CN" altLang="en-US" sz="6400" b="1" dirty="0">
                 <a:solidFill>
                   <a:srgbClr val="000066"/>
                 </a:solidFill>
                 <a:latin typeface="Microsoft JhengHei" panose="020B0604030504040204" pitchFamily="34" charset="-120"/>
                 <a:ea typeface="Microsoft JhengHei" panose="020B0604030504040204" pitchFamily="34" charset="-120"/>
               </a:rPr>
-              <a:t>主曾受</a:t>
-            </a:r>
-            <a:r>
-              <a:rPr lang="zh-CN" altLang="en-US" sz="6400" b="1" dirty="0">
-                <a:solidFill>
-                  <a:srgbClr val="000066"/>
-                </a:solidFill>
-                <a:latin typeface="Microsoft JhengHei" panose="020B0604030504040204" pitchFamily="34" charset="-120"/>
-                <a:ea typeface="Microsoft JhengHei" panose="020B0604030504040204" pitchFamily="34" charset="-120"/>
-              </a:rPr>
-              <a:t>試探  與我們無殊</a:t>
+              <a:t>主曾受試探  與我們無殊</a:t>
             </a:r>
             <a:endParaRPr lang="en-US" altLang="zh-CN" sz="6400" b="1" dirty="0">
               <a:solidFill>
@@ -3553,12 +3521,12 @@
           <a:p>
             <a:pPr algn="ctr"/>
             <a:r>
-              <a:rPr lang="en-US" sz="5400" b="1" dirty="0" smtClean="0">
+              <a:rPr lang="en-US" sz="5400" b="1" dirty="0">
                 <a:solidFill>
                   <a:srgbClr val="000066"/>
                 </a:solidFill>
               </a:rPr>
-              <a:t>( 3 )</a:t>
+              <a:t>( 3 / 4 )</a:t>
             </a:r>
             <a:endParaRPr lang="vi-VN" sz="5400" b="1" dirty="0">
               <a:solidFill>
@@ -3571,20 +3539,13 @@
     </p:spTree>
     <p:extLst>
       <p:ext uri="{BB962C8B-B14F-4D97-AF65-F5344CB8AC3E}">
-        <p14:creationId xmlns="" xmlns:p14="http://schemas.microsoft.com/office/powerpoint/2010/main" val="1966579155"/>
+        <p14:creationId xmlns:p14="http://schemas.microsoft.com/office/powerpoint/2010/main" val="1966579155"/>
       </p:ext>
     </p:extLst>
   </p:cSld>
   <p:clrMapOvr>
     <a:masterClrMapping/>
   </p:clrMapOvr>
-  <p:timing>
-    <p:tnLst>
-      <p:par>
-        <p:cTn id="1" dur="indefinite" restart="never" nodeType="tmRoot"/>
-      </p:par>
-    </p:tnLst>
-  </p:timing>
 </p:sld>
 </file>
 
@@ -3671,20 +3632,13 @@
     </p:spTree>
     <p:extLst>
       <p:ext uri="{BB962C8B-B14F-4D97-AF65-F5344CB8AC3E}">
-        <p14:creationId xmlns="" xmlns:p14="http://schemas.microsoft.com/office/powerpoint/2010/main" val="396892036"/>
+        <p14:creationId xmlns:p14="http://schemas.microsoft.com/office/powerpoint/2010/main" val="396892036"/>
       </p:ext>
     </p:extLst>
   </p:cSld>
   <p:clrMapOvr>
     <a:masterClrMapping/>
   </p:clrMapOvr>
-  <p:timing>
-    <p:tnLst>
-      <p:par>
-        <p:cTn id="1" dur="indefinite" restart="never" nodeType="tmRoot"/>
-      </p:par>
-    </p:tnLst>
-  </p:timing>
 </p:sld>
 </file>
 
@@ -3771,20 +3725,13 @@
     </p:spTree>
     <p:extLst>
       <p:ext uri="{BB962C8B-B14F-4D97-AF65-F5344CB8AC3E}">
-        <p14:creationId xmlns="" xmlns:p14="http://schemas.microsoft.com/office/powerpoint/2010/main" val="459364010"/>
+        <p14:creationId xmlns:p14="http://schemas.microsoft.com/office/powerpoint/2010/main" val="459364010"/>
       </p:ext>
     </p:extLst>
   </p:cSld>
   <p:clrMapOvr>
     <a:masterClrMapping/>
   </p:clrMapOvr>
-  <p:timing>
-    <p:tnLst>
-      <p:par>
-        <p:cTn id="1" dur="indefinite" restart="never" nodeType="tmRoot"/>
-      </p:par>
-    </p:tnLst>
-  </p:timing>
 </p:sld>
 </file>
 
@@ -3896,12 +3843,12 @@
           <a:p>
             <a:pPr algn="ctr"/>
             <a:r>
-              <a:rPr lang="en-US" sz="5400" b="1" dirty="0" smtClean="0">
+              <a:rPr lang="en-US" sz="5400" b="1" dirty="0">
                 <a:solidFill>
                   <a:srgbClr val="000066"/>
                 </a:solidFill>
               </a:rPr>
-              <a:t>( 4 )</a:t>
+              <a:t>( 4 / 4 )</a:t>
             </a:r>
             <a:endParaRPr lang="vi-VN" sz="5400" b="1" dirty="0">
               <a:solidFill>
@@ -3914,20 +3861,13 @@
     </p:spTree>
     <p:extLst>
       <p:ext uri="{BB962C8B-B14F-4D97-AF65-F5344CB8AC3E}">
-        <p14:creationId xmlns="" xmlns:p14="http://schemas.microsoft.com/office/powerpoint/2010/main" val="664523566"/>
+        <p14:creationId xmlns:p14="http://schemas.microsoft.com/office/powerpoint/2010/main" val="664523566"/>
       </p:ext>
     </p:extLst>
   </p:cSld>
   <p:clrMapOvr>
     <a:masterClrMapping/>
   </p:clrMapOvr>
-  <p:timing>
-    <p:tnLst>
-      <p:par>
-        <p:cTn id="1" dur="indefinite" restart="never" nodeType="tmRoot"/>
-      </p:par>
-    </p:tnLst>
-  </p:timing>
 </p:sld>
 </file>
 
@@ -4038,12 +3978,12 @@
           <a:p>
             <a:pPr algn="ctr"/>
             <a:r>
-              <a:rPr lang="en-US" sz="5400" b="1" dirty="0" smtClean="0">
+              <a:rPr lang="en-US" sz="5400" b="1" dirty="0">
                 <a:solidFill>
                   <a:srgbClr val="000066"/>
                 </a:solidFill>
               </a:rPr>
-              <a:t>( 4 )</a:t>
+              <a:t>( 4 / 4 )</a:t>
             </a:r>
             <a:endParaRPr lang="vi-VN" sz="5400" b="1" dirty="0">
               <a:solidFill>
@@ -4056,20 +3996,13 @@
     </p:spTree>
     <p:extLst>
       <p:ext uri="{BB962C8B-B14F-4D97-AF65-F5344CB8AC3E}">
-        <p14:creationId xmlns="" xmlns:p14="http://schemas.microsoft.com/office/powerpoint/2010/main" val="1141748893"/>
+        <p14:creationId xmlns:p14="http://schemas.microsoft.com/office/powerpoint/2010/main" val="1141748893"/>
       </p:ext>
     </p:extLst>
   </p:cSld>
   <p:clrMapOvr>
     <a:masterClrMapping/>
   </p:clrMapOvr>
-  <p:timing>
-    <p:tnLst>
-      <p:par>
-        <p:cTn id="1" dur="indefinite" restart="never" nodeType="tmRoot"/>
-      </p:par>
-    </p:tnLst>
-  </p:timing>
 </p:sld>
 </file>
 
@@ -4156,20 +4089,13 @@
     </p:spTree>
     <p:extLst>
       <p:ext uri="{BB962C8B-B14F-4D97-AF65-F5344CB8AC3E}">
-        <p14:creationId xmlns="" xmlns:p14="http://schemas.microsoft.com/office/powerpoint/2010/main" val="3676173359"/>
+        <p14:creationId xmlns:p14="http://schemas.microsoft.com/office/powerpoint/2010/main" val="3676173359"/>
       </p:ext>
     </p:extLst>
   </p:cSld>
   <p:clrMapOvr>
     <a:masterClrMapping/>
   </p:clrMapOvr>
-  <p:timing>
-    <p:tnLst>
-      <p:par>
-        <p:cTn id="1" dur="indefinite" restart="never" nodeType="tmRoot"/>
-      </p:par>
-    </p:tnLst>
-  </p:timing>
 </p:sld>
 </file>
 
@@ -4256,20 +4182,13 @@
     </p:spTree>
     <p:extLst>
       <p:ext uri="{BB962C8B-B14F-4D97-AF65-F5344CB8AC3E}">
-        <p14:creationId xmlns="" xmlns:p14="http://schemas.microsoft.com/office/powerpoint/2010/main" val="1314084251"/>
+        <p14:creationId xmlns:p14="http://schemas.microsoft.com/office/powerpoint/2010/main" val="1314084251"/>
       </p:ext>
     </p:extLst>
   </p:cSld>
   <p:clrMapOvr>
     <a:masterClrMapping/>
   </p:clrMapOvr>
-  <p:timing>
-    <p:tnLst>
-      <p:par>
-        <p:cTn id="1" dur="indefinite" restart="never" nodeType="tmRoot"/>
-      </p:par>
-    </p:tnLst>
-  </p:timing>
 </p:sld>
 </file>
 
@@ -4381,12 +4300,12 @@
           <a:p>
             <a:pPr algn="ctr"/>
             <a:r>
-              <a:rPr lang="en-US" sz="5400" b="1" dirty="0" smtClean="0">
+              <a:rPr lang="en-US" sz="5400" b="1" dirty="0">
                 <a:solidFill>
                   <a:srgbClr val="000066"/>
                 </a:solidFill>
               </a:rPr>
-              <a:t>( 1 )</a:t>
+              <a:t>( 1 / 4 )</a:t>
             </a:r>
             <a:endParaRPr lang="vi-VN" sz="5400" b="1" dirty="0">
               <a:solidFill>
@@ -4399,20 +4318,13 @@
     </p:spTree>
     <p:extLst>
       <p:ext uri="{BB962C8B-B14F-4D97-AF65-F5344CB8AC3E}">
-        <p14:creationId xmlns="" xmlns:p14="http://schemas.microsoft.com/office/powerpoint/2010/main" val="1588327362"/>
+        <p14:creationId xmlns:p14="http://schemas.microsoft.com/office/powerpoint/2010/main" val="1588327362"/>
       </p:ext>
     </p:extLst>
   </p:cSld>
   <p:clrMapOvr>
     <a:masterClrMapping/>
   </p:clrMapOvr>
-  <p:timing>
-    <p:tnLst>
-      <p:par>
-        <p:cTn id="1" dur="indefinite" restart="never" nodeType="tmRoot"/>
-      </p:par>
-    </p:tnLst>
-  </p:timing>
 </p:sld>
 </file>
 
@@ -4524,12 +4436,12 @@
           <a:p>
             <a:pPr algn="ctr"/>
             <a:r>
-              <a:rPr lang="en-US" sz="5400" b="1" dirty="0" smtClean="0">
+              <a:rPr lang="en-US" sz="5400" b="1" dirty="0">
                 <a:solidFill>
                   <a:srgbClr val="000066"/>
                 </a:solidFill>
               </a:rPr>
-              <a:t>( 1 )</a:t>
+              <a:t>( 1 / 4 )</a:t>
             </a:r>
             <a:endParaRPr lang="vi-VN" sz="5400" b="1" dirty="0">
               <a:solidFill>
@@ -4542,20 +4454,13 @@
     </p:spTree>
     <p:extLst>
       <p:ext uri="{BB962C8B-B14F-4D97-AF65-F5344CB8AC3E}">
-        <p14:creationId xmlns="" xmlns:p14="http://schemas.microsoft.com/office/powerpoint/2010/main" val="2958117696"/>
+        <p14:creationId xmlns:p14="http://schemas.microsoft.com/office/powerpoint/2010/main" val="2958117696"/>
       </p:ext>
     </p:extLst>
   </p:cSld>
   <p:clrMapOvr>
     <a:masterClrMapping/>
   </p:clrMapOvr>
-  <p:timing>
-    <p:tnLst>
-      <p:par>
-        <p:cTn id="1" dur="indefinite" restart="never" nodeType="tmRoot"/>
-      </p:par>
-    </p:tnLst>
-  </p:timing>
 </p:sld>
 </file>
 
@@ -4646,20 +4551,13 @@
     </p:spTree>
     <p:extLst>
       <p:ext uri="{BB962C8B-B14F-4D97-AF65-F5344CB8AC3E}">
-        <p14:creationId xmlns="" xmlns:p14="http://schemas.microsoft.com/office/powerpoint/2010/main" val="2999927471"/>
+        <p14:creationId xmlns:p14="http://schemas.microsoft.com/office/powerpoint/2010/main" val="2999927471"/>
       </p:ext>
     </p:extLst>
   </p:cSld>
   <p:clrMapOvr>
     <a:masterClrMapping/>
   </p:clrMapOvr>
-  <p:timing>
-    <p:tnLst>
-      <p:par>
-        <p:cTn id="1" dur="indefinite" restart="never" nodeType="tmRoot"/>
-      </p:par>
-    </p:tnLst>
-  </p:timing>
 </p:sld>
 </file>
 
@@ -4750,20 +4648,13 @@
     </p:spTree>
     <p:extLst>
       <p:ext uri="{BB962C8B-B14F-4D97-AF65-F5344CB8AC3E}">
-        <p14:creationId xmlns="" xmlns:p14="http://schemas.microsoft.com/office/powerpoint/2010/main" val="2751514151"/>
+        <p14:creationId xmlns:p14="http://schemas.microsoft.com/office/powerpoint/2010/main" val="2751514151"/>
       </p:ext>
     </p:extLst>
   </p:cSld>
   <p:clrMapOvr>
     <a:masterClrMapping/>
   </p:clrMapOvr>
-  <p:timing>
-    <p:tnLst>
-      <p:par>
-        <p:cTn id="1" dur="indefinite" restart="never" nodeType="tmRoot"/>
-      </p:par>
-    </p:tnLst>
-  </p:timing>
 </p:sld>
 </file>
 
@@ -4875,12 +4766,12 @@
           <a:p>
             <a:pPr algn="ctr"/>
             <a:r>
-              <a:rPr lang="en-US" sz="5400" b="1" dirty="0" smtClean="0">
+              <a:rPr lang="en-US" sz="5400" b="1" dirty="0">
                 <a:solidFill>
                   <a:srgbClr val="000066"/>
                 </a:solidFill>
               </a:rPr>
-              <a:t>( 2 )</a:t>
+              <a:t>( 2 / 4 )</a:t>
             </a:r>
             <a:endParaRPr lang="vi-VN" sz="5400" b="1" dirty="0">
               <a:solidFill>
@@ -4893,20 +4784,13 @@
     </p:spTree>
     <p:extLst>
       <p:ext uri="{BB962C8B-B14F-4D97-AF65-F5344CB8AC3E}">
-        <p14:creationId xmlns="" xmlns:p14="http://schemas.microsoft.com/office/powerpoint/2010/main" val="1607312750"/>
+        <p14:creationId xmlns:p14="http://schemas.microsoft.com/office/powerpoint/2010/main" val="1607312750"/>
       </p:ext>
     </p:extLst>
   </p:cSld>
   <p:clrMapOvr>
     <a:masterClrMapping/>
   </p:clrMapOvr>
-  <p:timing>
-    <p:tnLst>
-      <p:par>
-        <p:cTn id="1" dur="indefinite" restart="never" nodeType="tmRoot"/>
-      </p:par>
-    </p:tnLst>
-  </p:timing>
 </p:sld>
 </file>
 
@@ -5018,12 +4902,12 @@
           <a:p>
             <a:pPr algn="ctr"/>
             <a:r>
-              <a:rPr lang="en-US" sz="5400" b="1" dirty="0" smtClean="0">
+              <a:rPr lang="en-US" sz="5400" b="1" dirty="0">
                 <a:solidFill>
                   <a:srgbClr val="000066"/>
                 </a:solidFill>
               </a:rPr>
-              <a:t>( 2 )</a:t>
+              <a:t>( 2 / 4 )</a:t>
             </a:r>
             <a:endParaRPr lang="vi-VN" sz="5400" b="1" dirty="0">
               <a:solidFill>
@@ -5036,20 +4920,13 @@
     </p:spTree>
     <p:extLst>
       <p:ext uri="{BB962C8B-B14F-4D97-AF65-F5344CB8AC3E}">
-        <p14:creationId xmlns="" xmlns:p14="http://schemas.microsoft.com/office/powerpoint/2010/main" val="3807481253"/>
+        <p14:creationId xmlns:p14="http://schemas.microsoft.com/office/powerpoint/2010/main" val="3807481253"/>
       </p:ext>
     </p:extLst>
   </p:cSld>
   <p:clrMapOvr>
     <a:masterClrMapping/>
   </p:clrMapOvr>
-  <p:timing>
-    <p:tnLst>
-      <p:par>
-        <p:cTn id="1" dur="indefinite" restart="never" nodeType="tmRoot"/>
-      </p:par>
-    </p:tnLst>
-  </p:timing>
 </p:sld>
 </file>
 
@@ -5140,20 +5017,13 @@
     </p:spTree>
     <p:extLst>
       <p:ext uri="{BB962C8B-B14F-4D97-AF65-F5344CB8AC3E}">
-        <p14:creationId xmlns="" xmlns:p14="http://schemas.microsoft.com/office/powerpoint/2010/main" val="609985117"/>
+        <p14:creationId xmlns:p14="http://schemas.microsoft.com/office/powerpoint/2010/main" val="609985117"/>
       </p:ext>
     </p:extLst>
   </p:cSld>
   <p:clrMapOvr>
     <a:masterClrMapping/>
   </p:clrMapOvr>
-  <p:timing>
-    <p:tnLst>
-      <p:par>
-        <p:cTn id="1" dur="indefinite" restart="never" nodeType="tmRoot"/>
-      </p:par>
-    </p:tnLst>
-  </p:timing>
 </p:sld>
 </file>
 
@@ -5244,20 +5114,13 @@
     </p:spTree>
     <p:extLst>
       <p:ext uri="{BB962C8B-B14F-4D97-AF65-F5344CB8AC3E}">
-        <p14:creationId xmlns="" xmlns:p14="http://schemas.microsoft.com/office/powerpoint/2010/main" val="1332903155"/>
+        <p14:creationId xmlns:p14="http://schemas.microsoft.com/office/powerpoint/2010/main" val="1332903155"/>
       </p:ext>
     </p:extLst>
   </p:cSld>
   <p:clrMapOvr>
     <a:masterClrMapping/>
   </p:clrMapOvr>
-  <p:timing>
-    <p:tnLst>
-      <p:par>
-        <p:cTn id="1" dur="indefinite" restart="never" nodeType="tmRoot"/>
-      </p:par>
-    </p:tnLst>
-  </p:timing>
 </p:sld>
 </file>
 
@@ -5543,7 +5406,7 @@
   <a:extraClrSchemeLst/>
   <a:extLst>
     <a:ext uri="{05A4C25C-085E-4340-85A3-A5531E510DB2}">
-      <thm15:themeFamily xmlns="" xmlns:thm15="http://schemas.microsoft.com/office/thememl/2012/main" name="Theme1" id="{AFC7C034-021A-479F-A5B0-F4AE2AC2A6F8}" vid="{E4B01A5C-7C0B-4AB8-8973-047186F18E30}"/>
+      <thm15:themeFamily xmlns:thm15="http://schemas.microsoft.com/office/thememl/2012/main" name="Theme1" id="{AFC7C034-021A-479F-A5B0-F4AE2AC2A6F8}" vid="{E4B01A5C-7C0B-4AB8-8973-047186F18E30}"/>
     </a:ext>
   </a:extLst>
 </a:theme>

</xml_diff>